<commit_message>
修复 sales_by_person 命名统一 + data-insight skill 优化
</commit_message>
<xml_diff>
--- a/templates/销售分析报告_标准模板.pptx
+++ b/templates/销售分析报告_标准模板.pptx
@@ -3772,6 +3772,124 @@
           </a:p>
         </p:txBody>
       </p:sp>
+      <p:sp>
+        <p:nvSpPr>
+          <p:cNvPr id="3" name="文本框 2">
+            <a:extLst>
+              <a:ext uri="{FF2B5EF4-FFF2-40B4-BE49-F238E27FC236}">
+                <a16:creationId xmlns:a16="http://schemas.microsoft.com/office/drawing/2014/main" id="{29A9A806-473D-37B7-BE4F-455A7EF285BA}"/>
+              </a:ext>
+            </a:extLst>
+          </p:cNvPr>
+          <p:cNvSpPr txBox="1"/>
+          <p:nvPr/>
+        </p:nvSpPr>
+        <p:spPr>
+          <a:xfrm>
+            <a:off x="1705855" y="3672968"/>
+            <a:ext cx="184731" cy="369332"/>
+          </a:xfrm>
+          <a:prstGeom prst="rect">
+            <a:avLst/>
+          </a:prstGeom>
+          <a:noFill/>
+        </p:spPr>
+        <p:txBody>
+          <a:bodyPr wrap="none" rtlCol="0">
+            <a:spAutoFit/>
+          </a:bodyPr>
+          <a:lstStyle/>
+          <a:p>
+            <a:endParaRPr lang="zh-CN" altLang="en-US" dirty="0"/>
+          </a:p>
+        </p:txBody>
+      </p:sp>
+      <p:graphicFrame>
+        <p:nvGraphicFramePr>
+          <p:cNvPr id="4" name="表格 3">
+            <a:extLst>
+              <a:ext uri="{FF2B5EF4-FFF2-40B4-BE49-F238E27FC236}">
+                <a16:creationId xmlns:a16="http://schemas.microsoft.com/office/drawing/2014/main" id="{E12609E2-21A8-EA49-5410-6F3BD7BCE3B9}"/>
+              </a:ext>
+            </a:extLst>
+          </p:cNvPr>
+          <p:cNvGraphicFramePr>
+            <a:graphicFrameLocks noGrp="1"/>
+          </p:cNvGraphicFramePr>
+          <p:nvPr>
+            <p:extLst>
+              <p:ext uri="{D42A27DB-BD31-4B8C-83A1-F6EECF244321}">
+                <p14:modId xmlns:p14="http://schemas.microsoft.com/office/powerpoint/2010/main" val="1065494781"/>
+              </p:ext>
+            </p:extLst>
+          </p:nvPr>
+        </p:nvGraphicFramePr>
+        <p:xfrm>
+          <a:off x="389964" y="1681819"/>
+          <a:ext cx="2631782" cy="365760"/>
+        </p:xfrm>
+        <a:graphic>
+          <a:graphicData uri="http://schemas.openxmlformats.org/drawingml/2006/table">
+            <a:tbl>
+              <a:tblPr/>
+              <a:tblGrid>
+                <a:gridCol w="2631782">
+                  <a:extLst>
+                    <a:ext uri="{9D8B030D-6E8A-4147-A177-3AD203B41FA5}">
+                      <a16:colId xmlns:a16="http://schemas.microsoft.com/office/drawing/2014/main" val="3595657301"/>
+                    </a:ext>
+                  </a:extLst>
+                </a:gridCol>
+              </a:tblGrid>
+              <a:tr h="0">
+                <a:tc>
+                  <a:txBody>
+                    <a:bodyPr/>
+                    <a:lstStyle/>
+                    <a:p>
+                      <a:pPr>
+                        <a:buNone/>
+                      </a:pPr>
+                      <a:r>
+                        <a:rPr lang="en-US" dirty="0"/>
+                        <a:t>{{</a:t>
+                      </a:r>
+                      <a:r>
+                        <a:rPr lang="en-US" dirty="0" err="1"/>
+                        <a:t>INSIGHT:customer_city</a:t>
+                      </a:r>
+                      <a:r>
+                        <a:rPr lang="en-US" dirty="0"/>
+                        <a:t>}}</a:t>
+                      </a:r>
+                    </a:p>
+                  </a:txBody>
+                  <a:tcPr anchor="ctr">
+                    <a:lnL>
+                      <a:noFill/>
+                    </a:lnL>
+                    <a:lnR>
+                      <a:noFill/>
+                    </a:lnR>
+                    <a:lnT>
+                      <a:noFill/>
+                    </a:lnT>
+                    <a:lnB>
+                      <a:noFill/>
+                    </a:lnB>
+                    <a:noFill/>
+                  </a:tcPr>
+                </a:tc>
+                <a:extLst>
+                  <a:ext uri="{0D108BD9-81ED-4DB2-BD59-A6C34878D82A}">
+                    <a16:rowId xmlns:a16="http://schemas.microsoft.com/office/drawing/2014/main" val="1495118108"/>
+                  </a:ext>
+                </a:extLst>
+              </a:tr>
+            </a:tbl>
+          </a:graphicData>
+        </a:graphic>
+      </p:graphicFrame>
     </p:spTree>
     <p:extLst>
       <p:ext uri="{BB962C8B-B14F-4D97-AF65-F5344CB8AC3E}">
@@ -4288,7 +4406,7 @@
         <p:spPr>
           <a:xfrm>
             <a:off x="8046720" y="1371600"/>
-            <a:ext cx="3657600" cy="4114800"/>
+            <a:ext cx="2907142" cy="369332"/>
           </a:xfrm>
           <a:prstGeom prst="rect">
             <a:avLst/>
@@ -4307,7 +4425,15 @@
             </a:r>
             <a:r>
               <a:rPr dirty="0" err="1"/>
-              <a:t>INSIGHT:sales_person</a:t>
+              <a:t>INSIGHT:</a:t>
+            </a:r>
+            <a:r>
+              <a:rPr lang="en-US" altLang="zh-CN" dirty="0" err="1"/>
+              <a:t>sales_by_person</a:t>
+            </a:r>
+            <a:r>
+              <a:rPr lang="en-US" altLang="zh-CN" dirty="0"/>
+              <a:t> </a:t>
             </a:r>
             <a:r>
               <a:rPr dirty="0"/>
@@ -4434,7 +4560,7 @@
         <p:spPr>
           <a:xfrm>
             <a:off x="5760720" y="1371600"/>
-            <a:ext cx="5943600" cy="5029200"/>
+            <a:ext cx="2437270" cy="369332"/>
           </a:xfrm>
           <a:prstGeom prst="rect">
             <a:avLst/>
@@ -4448,7 +4574,20 @@
           <a:lstStyle/>
           <a:p>
             <a:r>
-              <a:t>{{INSIGHT:product}}</a:t>
+              <a:rPr dirty="0"/>
+              <a:t>{{</a:t>
+            </a:r>
+            <a:r>
+              <a:rPr dirty="0" err="1"/>
+              <a:t>INSIGHT:</a:t>
+            </a:r>
+            <a:r>
+              <a:rPr lang="en-US" dirty="0" err="1"/>
+              <a:t>product_pie</a:t>
+            </a:r>
+            <a:r>
+              <a:rPr dirty="0"/>
+              <a:t>}}</a:t>
             </a:r>
           </a:p>
         </p:txBody>
@@ -4571,7 +4710,7 @@
         <p:spPr>
           <a:xfrm>
             <a:off x="8046720" y="1371600"/>
-            <a:ext cx="3657600" cy="4114800"/>
+            <a:ext cx="2436244" cy="369332"/>
           </a:xfrm>
           <a:prstGeom prst="rect">
             <a:avLst/>
@@ -4585,7 +4724,20 @@
           <a:lstStyle/>
           <a:p>
             <a:r>
-              <a:t>{{INSIGHT:city}}</a:t>
+              <a:rPr dirty="0"/>
+              <a:t>{{</a:t>
+            </a:r>
+            <a:r>
+              <a:rPr dirty="0" err="1"/>
+              <a:t>INSIGHT:</a:t>
+            </a:r>
+            <a:r>
+              <a:rPr lang="en-US" dirty="0" err="1"/>
+              <a:t>city_ranking</a:t>
+            </a:r>
+            <a:r>
+              <a:rPr dirty="0"/>
+              <a:t>}}</a:t>
             </a:r>
           </a:p>
         </p:txBody>
@@ -4708,7 +4860,7 @@
         <p:spPr>
           <a:xfrm>
             <a:off x="8046720" y="1371600"/>
-            <a:ext cx="3657600" cy="4114800"/>
+            <a:ext cx="3392852" cy="369332"/>
           </a:xfrm>
           <a:prstGeom prst="rect">
             <a:avLst/>
@@ -4727,7 +4879,11 @@
             </a:r>
             <a:r>
               <a:rPr dirty="0" err="1"/>
-              <a:t>INSIGHT:customer</a:t>
+              <a:t>INSIGHT:</a:t>
+            </a:r>
+            <a:r>
+              <a:rPr lang="en-US" dirty="0" err="1"/>
+              <a:t>customer_comparison</a:t>
             </a:r>
             <a:r>
               <a:rPr dirty="0"/>
@@ -4770,7 +4926,7 @@
         <p:spPr>
           <a:xfrm>
             <a:off x="457200" y="5212080"/>
-            <a:ext cx="11277295" cy="1188720"/>
+            <a:ext cx="2703561" cy="369332"/>
           </a:xfrm>
           <a:prstGeom prst="rect">
             <a:avLst/>
@@ -4789,7 +4945,11 @@
             </a:r>
             <a:r>
               <a:rPr dirty="0" err="1"/>
-              <a:t>INSIGHT:trend</a:t>
+              <a:t>INSIGHT:</a:t>
+            </a:r>
+            <a:r>
+              <a:rPr lang="en-US" dirty="0" err="1"/>
+              <a:t>monthly_trend</a:t>
             </a:r>
             <a:r>
               <a:rPr dirty="0"/>
@@ -5026,7 +5186,16 @@
           <a:lstStyle/>
           <a:p>
             <a:r>
-              <a:t>{{INSIGHT:heatmap}}</a:t>
+              <a:rPr dirty="0"/>
+              <a:t>{{</a:t>
+            </a:r>
+            <a:r>
+              <a:rPr dirty="0" err="1"/>
+              <a:t>INSIGHT:heatmap</a:t>
+            </a:r>
+            <a:r>
+              <a:rPr dirty="0"/>
+              <a:t>}}</a:t>
             </a:r>
           </a:p>
         </p:txBody>

</xml_diff>